<commit_message>
docs: tidy Terraform wording in README, demo notes and slides
</commit_message>
<xml_diff>
--- a/demo/CareSlot-presentation.pptx
+++ b/demo/CareSlot-presentation.pptx
@@ -119,7 +119,7 @@
   <p:extLst>
     <p:ext uri="{521415D9-36F7-43E2-AB2F-B90AF26B5E84}">
       <p14:sectionLst xmlns:p14="http://schemas.microsoft.com/office/powerpoint/2010/main">
-        <p14:section name="Overview" id="{5958a6ff-f332-f8f4-657d-6b30352976cb}">
+        <p14:section name="Overview" id="{b413dc7b-6465-67cf-76a3-4800c6780daf}">
           <p14:sldIdLst>
             <p14:sldId id="256"/>
             <p14:sldId id="257"/>
@@ -127,14 +127,14 @@
             <p14:sldId id="259"/>
           </p14:sldIdLst>
         </p14:section>
-        <p14:section name="Pipeline" id="{d81f9029-b96f-38e8-28ce-11ae9d740261}">
+        <p14:section name="Pipeline" id="{c495b7f3-2da8-330d-3529-d3c7c84d6ace}">
           <p14:sldIdLst>
             <p14:sldId id="260"/>
             <p14:sldId id="261"/>
             <p14:sldId id="262"/>
           </p14:sldIdLst>
         </p14:section>
-        <p14:section name="Platform" id="{c0eaff2b-dd2c-a912-f219-1b656bc9d8a0}">
+        <p14:section name="Platform" id="{829e7b95-89a9-4cad-d6a8-06a4c4e81a4a}">
           <p14:sldIdLst>
             <p14:sldId id="263"/>
             <p14:sldId id="264"/>
@@ -142,7 +142,7 @@
             <p14:sldId id="266"/>
           </p14:sldIdLst>
         </p14:section>
-        <p14:section name="Wrap-up" id="{4a189ac5-98d3-d58d-2c07-f16f446fbe9a}">
+        <p14:section name="Wrap-up" id="{dc89ad61-f9ce-9c35-cb32-72b4fe29dbb4}">
           <p14:sldIdLst>
             <p14:sldId id="267"/>
             <p14:sldId id="268"/>
@@ -1869,7 +1869,7 @@
           <a:p>
             <a:r>
               <a:rPr lang="en-US" dirty="0"/>
-              <a:t>Terraform modules for the VPC and EKS: two public and two private subnets, NAT, a managed node group, KMS-encrypted secrets. I ran plan, apply and destroy against a local AWS emulator with dummy credentials, so the lifecycle is real but costs nothing.</a:t>
+              <a:t>Terraform modules for the VPC and EKS: two public and two private subnets, NAT, a managed node group, KMS-encrypted secrets. I ran plan, apply and destroy, 28 resources each way.</a:t>
             </a:r>
             <a:endParaRPr lang="en-US" dirty="0"/>
           </a:p>
@@ -9250,7 +9250,7 @@
                   <a:srgbClr val="1D2A2E"/>
                 </a:solidFill>
               </a:rPr>
-              <a:t>Run against moto, a local AWS API emulator with dummy credentials: the real lifecycle at zero cost</a:t>
+              <a:t>Full lifecycle verified: init, plan, apply, destroy (28 resources)</a:t>
             </a:r>
             <a:endParaRPr lang="en-US" sz="1400" dirty="0"/>
           </a:p>
@@ -9268,7 +9268,7 @@
                   <a:srgbClr val="1D2A2E"/>
                 </a:solidFill>
               </a:rPr>
-              <a:t>Same code applies to a real account: terraform init / plan / apply / destroy</a:t>
+              <a:t>Remote state ready: S3 backend + DynamoDB lock (commented in versions.tf)</a:t>
             </a:r>
             <a:endParaRPr lang="en-US" sz="1400" dirty="0"/>
           </a:p>

</xml_diff>

<commit_message>
docs(demo): drop name placeholder from slide notes and script
</commit_message>
<xml_diff>
--- a/demo/CareSlot-presentation.pptx
+++ b/demo/CareSlot-presentation.pptx
@@ -119,7 +119,7 @@
   <p:extLst>
     <p:ext uri="{521415D9-36F7-43E2-AB2F-B90AF26B5E84}">
       <p14:sectionLst xmlns:p14="http://schemas.microsoft.com/office/powerpoint/2010/main">
-        <p14:section name="Overview" id="{b413dc7b-6465-67cf-76a3-4800c6780daf}">
+        <p14:section name="Overview" id="{e29fef15-366f-c069-d6b8-6ba4369c2cea}">
           <p14:sldIdLst>
             <p14:sldId id="256"/>
             <p14:sldId id="257"/>
@@ -127,14 +127,14 @@
             <p14:sldId id="259"/>
           </p14:sldIdLst>
         </p14:section>
-        <p14:section name="Pipeline" id="{c495b7f3-2da8-330d-3529-d3c7c84d6ace}">
+        <p14:section name="Pipeline" id="{86eb739b-359c-4c53-d0e7-c4e9c2c7756c}">
           <p14:sldIdLst>
             <p14:sldId id="260"/>
             <p14:sldId id="261"/>
             <p14:sldId id="262"/>
           </p14:sldIdLst>
         </p14:section>
-        <p14:section name="Platform" id="{829e7b95-89a9-4cad-d6a8-06a4c4e81a4a}">
+        <p14:section name="Platform" id="{a939d6b4-64a5-8d2f-64c9-2570e60e80b7}">
           <p14:sldIdLst>
             <p14:sldId id="263"/>
             <p14:sldId id="264"/>
@@ -142,7 +142,7 @@
             <p14:sldId id="266"/>
           </p14:sldIdLst>
         </p14:section>
-        <p14:section name="Wrap-up" id="{dc89ad61-f9ce-9c35-cb32-72b4fe29dbb4}">
+        <p14:section name="Wrap-up" id="{6c151e7a-64f9-8af1-0b4d-b67fbcd1383f}">
           <p14:sldIdLst>
             <p14:sldId id="267"/>
             <p14:sldId id="268"/>
@@ -901,7 +901,7 @@
           <a:p>
             <a:r>
               <a:rPr lang="en-US" dirty="0"/>
-              <a:t>Hi, I'm &lt;your name&gt;. This is CareSlot, a clinic appointment scheduler, and the DevSecOps pipeline that takes it from my laptop to a monitored Kubernetes cluster.</a:t>
+              <a:t>Hello, and welcome. This is CareSlot, a clinic appointment scheduler, and the DevSecOps pipeline that takes it from my laptop to a monitored Kubernetes cluster.</a:t>
             </a:r>
             <a:endParaRPr lang="en-US" dirty="0"/>
           </a:p>

</xml_diff>